<commit_message>
7k evaluation 31/31, feasibility report (math, latency, LLM cost), deck metrics
- plants: size the period-end concentration plant to the customer's run-rate (caught at any scale)
- docs/FEASIBILITY.md: soundness of each score/test, measured latency at 7k invoices, cost model per investigation
- deck results slide from docs/pitch/metrics.json; live-edit latency replaces the flat ablation callout
- vault: progress log + task board
</commit_message>
<xml_diff>
--- a/docs/pitch/AuditPilot_AI_ELEV01.pptx
+++ b/docs/pitch/AuditPilot_AI_ELEV01.pptx
@@ -119,38 +119,38 @@
   <p:extLst>
     <p:ext uri="{521415D9-36F7-43E2-AB2F-B90AF26B5E84}">
       <p14:sectionLst xmlns:p14="http://schemas.microsoft.com/office/powerpoint/2010/main">
-        <p14:section name="Opening" id="{0ad9734d-f61c-ea33-aa23-bf55429532fb}">
+        <p14:section name="Opening" id="{2748aeff-67e8-0185-fb2b-15c291723f31}">
           <p14:sldIdLst>
             <p14:sldId id="256"/>
             <p14:sldId id="257"/>
           </p14:sldIdLst>
         </p14:section>
-        <p14:section name="Solution" id="{46b6c605-cb69-fe62-d29f-0c589443b6eb}">
+        <p14:section name="Solution" id="{e756fb3a-7146-0757-6ef3-7b21385d06b7}">
           <p14:sldIdLst>
             <p14:sldId id="258"/>
             <p14:sldId id="259"/>
             <p14:sldId id="260"/>
           </p14:sldIdLst>
         </p14:section>
-        <p14:section name="Trust" id="{a370e550-9a04-7818-2720-71fc1044c199}">
+        <p14:section name="Trust" id="{2b20497b-a929-ecc9-11af-330ed7631b2e}">
           <p14:sldIdLst>
             <p14:sldId id="261"/>
           </p14:sldIdLst>
         </p14:section>
-        <p14:section name="Detection" id="{cc43ef3d-486c-5889-4bff-27d13f3cf552}">
+        <p14:section name="Detection" id="{caf675d0-3a87-e2a2-45fa-6a660a8298f6}">
           <p14:sldIdLst>
             <p14:sldId id="262"/>
             <p14:sldId id="263"/>
           </p14:sldIdLst>
         </p14:section>
-        <p14:section name="Evidence" id="{e95543f2-9b37-31a0-12d1-590792818270}">
+        <p14:section name="Evidence" id="{ce2a42f1-b199-7426-2140-e91a7c9674a0}">
           <p14:sldIdLst>
             <p14:sldId id="264"/>
             <p14:sldId id="265"/>
             <p14:sldId id="266"/>
           </p14:sldIdLst>
         </p14:section>
-        <p14:section name="Close" id="{3b8b667e-520d-b432-3586-24b7002c1fed}">
+        <p14:section name="Close" id="{90ffa0c0-d385-3689-0b86-24f2f9aff51e}">
           <p14:sldIdLst>
             <p14:sldId id="267"/>
             <p14:sldId id="268"/>
@@ -163,6 +163,307 @@
     </p:ext>
   </p:extLst>
 </p:presentation>
+</file>
+
+<file path=ppt/charts/chart1.xml><?xml version="1.0" encoding="utf-8"?>
+<c:chartSpace xmlns:c="http://schemas.openxmlformats.org/drawingml/2006/chart" xmlns:a="http://schemas.openxmlformats.org/drawingml/2006/main" xmlns:r="http://schemas.openxmlformats.org/officeDocument/2006/relationships">
+  <c:date1904 val="0"/>
+  <c:roundedCorners val="1"/>
+  <c:chart>
+    <c:title>
+      <c:tx>
+        <c:rich>
+          <a:bodyPr/>
+          <a:lstStyle/>
+          <a:p>
+            <a:pPr>
+              <a:defRPr sz="1200" b="0" i="0" u="none" strike="noStrike">
+                <a:solidFill>
+                  <a:srgbClr val="0B3D3A"/>
+                </a:solidFill>
+                <a:latin typeface="+mn-lt"/>
+              </a:defRPr>
+            </a:pPr>
+            <a:r>
+              <a:rPr sz="1200" b="0" i="0" u="none" strike="noStrike">
+                <a:solidFill>
+                  <a:srgbClr val="0B3D3A"/>
+                </a:solidFill>
+                <a:latin typeface="+mn-lt"/>
+              </a:rPr>
+              <a:t>Planted irregularities caught, by family (%)</a:t>
+            </a:r>
+          </a:p>
+        </c:rich>
+      </c:tx>
+      <c:layout/>
+      <c:overlay val="0"/>
+    </c:title>
+    <c:autoTitleDeleted val="0"/>
+    <c:plotArea>
+      <c:layout/>
+      <c:barChart>
+        <c:barDir val="bar"/>
+        <c:grouping val="clustered"/>
+        <c:varyColors val="0"/>
+        <c:ser>
+          <c:idx val="0"/>
+          <c:order val="0"/>
+          <c:tx>
+            <c:strRef>
+              <c:f>Sheet1!$B$1</c:f>
+              <c:strCache>
+                <c:ptCount val="1"/>
+                <c:pt idx="0">
+                  <c:v>Recall</c:v>
+                </c:pt>
+              </c:strCache>
+            </c:strRef>
+          </c:tx>
+          <c:spPr>
+            <a:solidFill>
+              <a:srgbClr val="0B7A6F"/>
+            </a:solidFill>
+            <a:effectLst/>
+          </c:spPr>
+          <c:invertIfNegative val="0"/>
+          <c:dLbls>
+            <c:numFmt formatCode="0&quot;%&quot;" sourceLinked="0"/>
+            <c:txPr>
+              <a:bodyPr/>
+              <a:lstStyle/>
+              <a:p>
+                <a:pPr>
+                  <a:defRPr b="0" i="0" strike="noStrike" sz="1000" u="none">
+                    <a:solidFill>
+                      <a:srgbClr val="000000"/>
+                    </a:solidFill>
+                    <a:latin typeface="+mn-lt"/>
+                  </a:defRPr>
+                </a:pPr>
+              </a:p>
+            </c:txPr>
+            <c:showLegendKey val="0"/>
+            <c:showVal val="1"/>
+            <c:showCatName val="0"/>
+            <c:showSerName val="0"/>
+            <c:showPercent val="0"/>
+            <c:showBubbleSize val="0"/>
+            <c:showLeaderLines val="0"/>
+          </c:dLbls>
+          <c:cat>
+            <c:multiLvlStrRef>
+              <c:f>Sheet1!$A$2:$A$11</c:f>
+              <c:multiLvlStrCache>
+                <c:ptCount val="10"/>
+                <c:lvl>
+                  <c:pt idx="0">
+                    <c:v>Undisclosed RP</c:v>
+                  </c:pt>
+                  <c:pt idx="1">
+                    <c:v>RP mid-period</c:v>
+                  </c:pt>
+                  <c:pt idx="2">
+                    <c:v>Cut-off</c:v>
+                  </c:pt>
+                  <c:pt idx="3">
+                    <c:v>No movement</c:v>
+                  </c:pt>
+                  <c:pt idx="4">
+                    <c:v>Concentration</c:v>
+                  </c:pt>
+                  <c:pt idx="5">
+                    <c:v>Statutory</c:v>
+                  </c:pt>
+                  <c:pt idx="6">
+                    <c:v>Non-sale revenue</c:v>
+                  </c:pt>
+                  <c:pt idx="7">
+                    <c:v>Credit notes</c:v>
+                  </c:pt>
+                  <c:pt idx="8">
+                    <c:v>Circular</c:v>
+                  </c:pt>
+                  <c:pt idx="9">
+                    <c:v>Register ≠ books</c:v>
+                  </c:pt>
+                </c:lvl>
+              </c:multiLvlStrCache>
+            </c:multiLvlStrRef>
+          </c:cat>
+          <c:val>
+            <c:numRef>
+              <c:f>Sheet1!$B$2:$B$11</c:f>
+              <c:numCache>
+                <c:formatCode>General</c:formatCode>
+                <c:ptCount val="10"/>
+                <c:pt idx="0">
+                  <c:v>100</c:v>
+                </c:pt>
+                <c:pt idx="1">
+                  <c:v>100</c:v>
+                </c:pt>
+                <c:pt idx="2">
+                  <c:v>100</c:v>
+                </c:pt>
+                <c:pt idx="3">
+                  <c:v>100</c:v>
+                </c:pt>
+                <c:pt idx="4">
+                  <c:v>100</c:v>
+                </c:pt>
+                <c:pt idx="5">
+                  <c:v>100</c:v>
+                </c:pt>
+                <c:pt idx="6">
+                  <c:v>100</c:v>
+                </c:pt>
+                <c:pt idx="7">
+                  <c:v>100</c:v>
+                </c:pt>
+                <c:pt idx="8">
+                  <c:v>100</c:v>
+                </c:pt>
+                <c:pt idx="9">
+                  <c:v>100</c:v>
+                </c:pt>
+              </c:numCache>
+            </c:numRef>
+          </c:val>
+        </c:ser>
+        <c:dLbls>
+          <c:numFmt formatCode="0&quot;%&quot;" sourceLinked="0"/>
+          <c:txPr>
+            <a:bodyPr/>
+            <a:lstStyle/>
+            <a:p>
+              <a:pPr>
+                <a:defRPr b="0" i="0" strike="noStrike" sz="1000" u="none">
+                  <a:solidFill>
+                    <a:srgbClr val="000000"/>
+                  </a:solidFill>
+                  <a:latin typeface="+mn-lt"/>
+                </a:defRPr>
+              </a:pPr>
+            </a:p>
+          </c:txPr>
+          <c:showLegendKey val="0"/>
+          <c:showVal val="1"/>
+          <c:showCatName val="0"/>
+          <c:showSerName val="0"/>
+          <c:showPercent val="0"/>
+          <c:showBubbleSize val="0"/>
+          <c:showLeaderLines val="0"/>
+        </c:dLbls>
+        <c:gapWidth val="150"/>
+        <c:overlap val="0"/>
+        <c:axId val="2094734554"/>
+        <c:axId val="2094734552"/>
+        <c:axId val="2094734556"/>
+      </c:barChart>
+      <c:catAx>
+        <c:axId val="2094734554"/>
+        <c:scaling>
+          <c:orientation val="minMax"/>
+        </c:scaling>
+        <c:delete val="0"/>
+        <c:axPos val="l"/>
+        <c:numFmt formatCode="General" sourceLinked="1"/>
+        <c:majorTickMark val="out"/>
+        <c:minorTickMark val="none"/>
+        <c:tickLblPos val="nextTo"/>
+        <c:spPr>
+          <a:ln w="12700" cap="flat">
+            <a:solidFill>
+              <a:srgbClr val="888888"/>
+            </a:solidFill>
+            <a:prstDash val="solid"/>
+            <a:round/>
+          </a:ln>
+        </c:spPr>
+        <c:txPr>
+          <a:bodyPr/>
+          <a:lstStyle/>
+          <a:p>
+            <a:pPr>
+              <a:defRPr sz="1000" b="0" i="0" u="none" strike="noStrike">
+                <a:solidFill>
+                  <a:srgbClr val="1B2A2A"/>
+                </a:solidFill>
+                <a:latin typeface="+mn-lt"/>
+              </a:defRPr>
+            </a:pPr>
+            <a:endParaRPr lang="en-US"/>
+          </a:p>
+        </c:txPr>
+        <c:crossAx val="2094734552"/>
+        <c:crosses val="autoZero"/>
+        <c:auto val="1"/>
+        <c:lblAlgn val="ctr"/>
+        <c:noMultiLvlLbl val="1"/>
+      </c:catAx>
+      <c:valAx>
+        <c:axId val="2094734552"/>
+        <c:scaling>
+          <c:orientation val="minMax"/>
+          <c:max val="110"/>
+        </c:scaling>
+        <c:delete val="1"/>
+        <c:axPos val="b"/>
+        <c:numFmt formatCode="General" sourceLinked="0"/>
+        <c:majorTickMark val="out"/>
+        <c:minorTickMark val="none"/>
+        <c:tickLblPos val="low"/>
+        <c:spPr>
+          <a:ln w="12700" cap="flat">
+            <a:solidFill>
+              <a:srgbClr val="888888"/>
+            </a:solidFill>
+            <a:prstDash val="solid"/>
+            <a:round/>
+          </a:ln>
+        </c:spPr>
+        <c:txPr>
+          <a:bodyPr/>
+          <a:lstStyle/>
+          <a:p>
+            <a:pPr>
+              <a:defRPr sz="1200" b="0" i="0" u="none" strike="noStrike">
+                <a:solidFill>
+                  <a:srgbClr val="000000"/>
+                </a:solidFill>
+                <a:latin typeface="Arial"/>
+              </a:defRPr>
+            </a:pPr>
+            <a:endParaRPr lang="en-US"/>
+          </a:p>
+        </c:txPr>
+        <c:crossAx val="2094734554"/>
+        <c:crosses val="autoZero"/>
+        <c:crossBetween val="between"/>
+      </c:valAx>
+      <c:spPr>
+        <a:noFill/>
+        <a:ln>
+          <a:noFill/>
+        </a:ln>
+        <a:effectLst/>
+      </c:spPr>
+    </c:plotArea>
+    <c:plotVisOnly val="1"/>
+    <c:dispBlanksAs val="span"/>
+  </c:chart>
+  <c:spPr>
+    <a:noFill/>
+    <a:ln>
+      <a:noFill/>
+    </a:ln>
+    <a:effectLst/>
+  </c:spPr>
+  <c:externalData r:id="rId1">
+    <c:autoUpdate val="0"/>
+  </c:externalData>
+</c:chartSpace>
 </file>
 
 <file path=ppt/notesMasters/notesMaster1.xml><?xml version="1.0" encoding="utf-8"?>
@@ -1616,7 +1917,7 @@
           <a:p>
             <a:r>
               <a:rPr lang="en-US" dirty="0"/>
-              <a:t>Numbers from python -m app.evaluate. The ablation compares transaction features only, plus graph features, plus entity risk: the measured benefit of AuditGraph.</a:t>
+              <a:t>Numbers from python -m app.demo_audit on 7,003 invoices with 31 planted irregularities: 31/31 caught, zero serious false alarms. Latency measured on a laptop CPU: upload to risk map under a minute; a live client edit re-scores that customer in about 1-3 s. Honest caveat: on this data the transaction-only ranking already puts every planted invoice in the top 30, so we don't claim a ranking lift from the graph; it earns its keep on the party view (round trips, undisclosed related parties). Full numbers in docs/FEASIBILITY.md.</a:t>
             </a:r>
             <a:endParaRPr lang="en-US" dirty="0"/>
           </a:p>
@@ -2448,7 +2749,7 @@
       </p:sp>
       <p:sp>
         <p:nvSpPr>
-          <p:cNvPr id="3" name="dot-180"/>
+          <p:cNvPr id="3" name="dot-179"/>
           <p:cNvSpPr/>
           <p:nvPr/>
         </p:nvSpPr>
@@ -2473,7 +2774,7 @@
       </p:sp>
       <p:sp>
         <p:nvSpPr>
-          <p:cNvPr id="4" name="text-181"/>
+          <p:cNvPr id="4" name="text-180"/>
           <p:cNvSpPr txBox="1"/>
           <p:nvPr/>
         </p:nvSpPr>
@@ -2509,7 +2810,7 @@
       </p:sp>
       <p:sp>
         <p:nvSpPr>
-          <p:cNvPr id="5" name="text-182"/>
+          <p:cNvPr id="5" name="text-181"/>
           <p:cNvSpPr txBox="1"/>
           <p:nvPr/>
         </p:nvSpPr>
@@ -2545,7 +2846,7 @@
       </p:sp>
       <p:sp>
         <p:nvSpPr>
-          <p:cNvPr id="6" name="dot-183"/>
+          <p:cNvPr id="6" name="dot-182"/>
           <p:cNvSpPr/>
           <p:nvPr/>
         </p:nvSpPr>
@@ -2570,7 +2871,7 @@
       </p:sp>
       <p:sp>
         <p:nvSpPr>
-          <p:cNvPr id="7" name="text-184"/>
+          <p:cNvPr id="7" name="text-183"/>
           <p:cNvSpPr txBox="1"/>
           <p:nvPr/>
         </p:nvSpPr>
@@ -2606,7 +2907,7 @@
       </p:sp>
       <p:sp>
         <p:nvSpPr>
-          <p:cNvPr id="8" name="text-185"/>
+          <p:cNvPr id="8" name="text-184"/>
           <p:cNvSpPr txBox="1"/>
           <p:nvPr/>
         </p:nvSpPr>
@@ -2642,7 +2943,7 @@
       </p:sp>
       <p:sp>
         <p:nvSpPr>
-          <p:cNvPr id="9" name="dot-186"/>
+          <p:cNvPr id="9" name="dot-185"/>
           <p:cNvSpPr/>
           <p:nvPr/>
         </p:nvSpPr>
@@ -2667,7 +2968,7 @@
       </p:sp>
       <p:sp>
         <p:nvSpPr>
-          <p:cNvPr id="10" name="text-187"/>
+          <p:cNvPr id="10" name="text-186"/>
           <p:cNvSpPr txBox="1"/>
           <p:nvPr/>
         </p:nvSpPr>
@@ -2703,7 +3004,7 @@
       </p:sp>
       <p:sp>
         <p:nvSpPr>
-          <p:cNvPr id="11" name="text-188"/>
+          <p:cNvPr id="11" name="text-187"/>
           <p:cNvSpPr txBox="1"/>
           <p:nvPr/>
         </p:nvSpPr>
@@ -2739,7 +3040,7 @@
       </p:sp>
       <p:sp>
         <p:nvSpPr>
-          <p:cNvPr id="12" name="dot-189"/>
+          <p:cNvPr id="12" name="dot-188"/>
           <p:cNvSpPr/>
           <p:nvPr/>
         </p:nvSpPr>
@@ -2764,7 +3065,7 @@
       </p:sp>
       <p:sp>
         <p:nvSpPr>
-          <p:cNvPr id="13" name="text-190"/>
+          <p:cNvPr id="13" name="text-189"/>
           <p:cNvSpPr txBox="1"/>
           <p:nvPr/>
         </p:nvSpPr>
@@ -2800,7 +3101,7 @@
       </p:sp>
       <p:sp>
         <p:nvSpPr>
-          <p:cNvPr id="14" name="text-191"/>
+          <p:cNvPr id="14" name="text-190"/>
           <p:cNvSpPr txBox="1"/>
           <p:nvPr/>
         </p:nvSpPr>
@@ -2836,7 +3137,7 @@
       </p:sp>
       <p:sp>
         <p:nvSpPr>
-          <p:cNvPr id="15" name="dot-192"/>
+          <p:cNvPr id="15" name="dot-191"/>
           <p:cNvSpPr/>
           <p:nvPr/>
         </p:nvSpPr>
@@ -2861,7 +3162,7 @@
       </p:sp>
       <p:sp>
         <p:nvSpPr>
-          <p:cNvPr id="16" name="text-193"/>
+          <p:cNvPr id="16" name="text-192"/>
           <p:cNvSpPr txBox="1"/>
           <p:nvPr/>
         </p:nvSpPr>
@@ -2897,7 +3198,7 @@
       </p:sp>
       <p:sp>
         <p:nvSpPr>
-          <p:cNvPr id="17" name="text-194"/>
+          <p:cNvPr id="17" name="text-193"/>
           <p:cNvSpPr txBox="1"/>
           <p:nvPr/>
         </p:nvSpPr>
@@ -2933,7 +3234,7 @@
       </p:sp>
       <p:sp>
         <p:nvSpPr>
-          <p:cNvPr id="18" name="dot-195"/>
+          <p:cNvPr id="18" name="dot-194"/>
           <p:cNvSpPr/>
           <p:nvPr/>
         </p:nvSpPr>
@@ -2958,7 +3259,7 @@
       </p:sp>
       <p:sp>
         <p:nvSpPr>
-          <p:cNvPr id="19" name="text-196"/>
+          <p:cNvPr id="19" name="text-195"/>
           <p:cNvSpPr txBox="1"/>
           <p:nvPr/>
         </p:nvSpPr>
@@ -2994,7 +3295,7 @@
       </p:sp>
       <p:sp>
         <p:nvSpPr>
-          <p:cNvPr id="20" name="text-197"/>
+          <p:cNvPr id="20" name="text-196"/>
           <p:cNvSpPr txBox="1"/>
           <p:nvPr/>
         </p:nvSpPr>
@@ -3141,7 +3442,7 @@
       </p:sp>
       <p:sp>
         <p:nvSpPr>
-          <p:cNvPr id="3" name="card-198"/>
+          <p:cNvPr id="3" name="card-197"/>
           <p:cNvSpPr/>
           <p:nvPr/>
         </p:nvSpPr>
@@ -3175,7 +3476,7 @@
       </p:sp>
       <p:sp>
         <p:nvSpPr>
-          <p:cNvPr id="4" name="dot-199"/>
+          <p:cNvPr id="4" name="dot-198"/>
           <p:cNvSpPr/>
           <p:nvPr/>
         </p:nvSpPr>
@@ -3200,7 +3501,7 @@
       </p:sp>
       <p:sp>
         <p:nvSpPr>
-          <p:cNvPr id="5" name="text-200"/>
+          <p:cNvPr id="5" name="text-199"/>
           <p:cNvSpPr txBox="1"/>
           <p:nvPr/>
         </p:nvSpPr>
@@ -3236,7 +3537,7 @@
       </p:sp>
       <p:sp>
         <p:nvSpPr>
-          <p:cNvPr id="6" name="text-201"/>
+          <p:cNvPr id="6" name="text-200"/>
           <p:cNvSpPr txBox="1"/>
           <p:nvPr/>
         </p:nvSpPr>
@@ -3272,7 +3573,7 @@
       </p:sp>
       <p:sp>
         <p:nvSpPr>
-          <p:cNvPr id="7" name="list-202"/>
+          <p:cNvPr id="7" name="list-201"/>
           <p:cNvSpPr txBox="1"/>
           <p:nvPr/>
         </p:nvSpPr>
@@ -3348,7 +3649,7 @@
       </p:sp>
       <p:sp>
         <p:nvSpPr>
-          <p:cNvPr id="8" name="card-203"/>
+          <p:cNvPr id="8" name="card-202"/>
           <p:cNvSpPr/>
           <p:nvPr/>
         </p:nvSpPr>
@@ -3382,7 +3683,7 @@
       </p:sp>
       <p:sp>
         <p:nvSpPr>
-          <p:cNvPr id="9" name="dot-204"/>
+          <p:cNvPr id="9" name="dot-203"/>
           <p:cNvSpPr/>
           <p:nvPr/>
         </p:nvSpPr>
@@ -3407,7 +3708,7 @@
       </p:sp>
       <p:sp>
         <p:nvSpPr>
-          <p:cNvPr id="10" name="text-205"/>
+          <p:cNvPr id="10" name="text-204"/>
           <p:cNvSpPr txBox="1"/>
           <p:nvPr/>
         </p:nvSpPr>
@@ -3443,7 +3744,7 @@
       </p:sp>
       <p:sp>
         <p:nvSpPr>
-          <p:cNvPr id="11" name="text-206"/>
+          <p:cNvPr id="11" name="text-205"/>
           <p:cNvSpPr txBox="1"/>
           <p:nvPr/>
         </p:nvSpPr>
@@ -3479,7 +3780,7 @@
       </p:sp>
       <p:sp>
         <p:nvSpPr>
-          <p:cNvPr id="12" name="list-207"/>
+          <p:cNvPr id="12" name="list-206"/>
           <p:cNvSpPr txBox="1"/>
           <p:nvPr/>
         </p:nvSpPr>
@@ -3555,7 +3856,7 @@
       </p:sp>
       <p:sp>
         <p:nvSpPr>
-          <p:cNvPr id="13" name="card-208"/>
+          <p:cNvPr id="13" name="card-207"/>
           <p:cNvSpPr/>
           <p:nvPr/>
         </p:nvSpPr>
@@ -3589,7 +3890,7 @@
       </p:sp>
       <p:sp>
         <p:nvSpPr>
-          <p:cNvPr id="14" name="dot-209"/>
+          <p:cNvPr id="14" name="dot-208"/>
           <p:cNvSpPr/>
           <p:nvPr/>
         </p:nvSpPr>
@@ -3614,7 +3915,7 @@
       </p:sp>
       <p:sp>
         <p:nvSpPr>
-          <p:cNvPr id="15" name="text-210"/>
+          <p:cNvPr id="15" name="text-209"/>
           <p:cNvSpPr txBox="1"/>
           <p:nvPr/>
         </p:nvSpPr>
@@ -3650,7 +3951,7 @@
       </p:sp>
       <p:sp>
         <p:nvSpPr>
-          <p:cNvPr id="16" name="text-211"/>
+          <p:cNvPr id="16" name="text-210"/>
           <p:cNvSpPr txBox="1"/>
           <p:nvPr/>
         </p:nvSpPr>
@@ -3686,7 +3987,7 @@
       </p:sp>
       <p:sp>
         <p:nvSpPr>
-          <p:cNvPr id="17" name="list-212"/>
+          <p:cNvPr id="17" name="list-211"/>
           <p:cNvSpPr txBox="1"/>
           <p:nvPr/>
         </p:nvSpPr>
@@ -3873,7 +4174,7 @@
       </p:sp>
       <p:sp>
         <p:nvSpPr>
-          <p:cNvPr id="3" name="card-213"/>
+          <p:cNvPr id="3" name="card-212"/>
           <p:cNvSpPr/>
           <p:nvPr/>
         </p:nvSpPr>
@@ -3907,7 +4208,7 @@
       </p:sp>
       <p:sp>
         <p:nvSpPr>
-          <p:cNvPr id="4" name="text-214"/>
+          <p:cNvPr id="4" name="text-213"/>
           <p:cNvSpPr txBox="1"/>
           <p:nvPr/>
         </p:nvSpPr>
@@ -3943,7 +4244,7 @@
       </p:sp>
       <p:sp>
         <p:nvSpPr>
-          <p:cNvPr id="5" name="text-215"/>
+          <p:cNvPr id="5" name="text-214"/>
           <p:cNvSpPr txBox="1"/>
           <p:nvPr/>
         </p:nvSpPr>
@@ -3979,7 +4280,7 @@
       </p:sp>
       <p:sp>
         <p:nvSpPr>
-          <p:cNvPr id="6" name="card-216"/>
+          <p:cNvPr id="6" name="card-215"/>
           <p:cNvSpPr/>
           <p:nvPr/>
         </p:nvSpPr>
@@ -4013,7 +4314,7 @@
       </p:sp>
       <p:sp>
         <p:nvSpPr>
-          <p:cNvPr id="7" name="text-217"/>
+          <p:cNvPr id="7" name="text-216"/>
           <p:cNvSpPr txBox="1"/>
           <p:nvPr/>
         </p:nvSpPr>
@@ -4049,7 +4350,7 @@
       </p:sp>
       <p:sp>
         <p:nvSpPr>
-          <p:cNvPr id="8" name="text-218"/>
+          <p:cNvPr id="8" name="text-217"/>
           <p:cNvSpPr txBox="1"/>
           <p:nvPr/>
         </p:nvSpPr>
@@ -4085,7 +4386,7 @@
       </p:sp>
       <p:sp>
         <p:nvSpPr>
-          <p:cNvPr id="9" name="card-219"/>
+          <p:cNvPr id="9" name="card-218"/>
           <p:cNvSpPr/>
           <p:nvPr/>
         </p:nvSpPr>
@@ -4119,7 +4420,7 @@
       </p:sp>
       <p:sp>
         <p:nvSpPr>
-          <p:cNvPr id="10" name="text-220"/>
+          <p:cNvPr id="10" name="text-219"/>
           <p:cNvSpPr txBox="1"/>
           <p:nvPr/>
         </p:nvSpPr>
@@ -4155,7 +4456,7 @@
       </p:sp>
       <p:sp>
         <p:nvSpPr>
-          <p:cNvPr id="11" name="text-221"/>
+          <p:cNvPr id="11" name="text-220"/>
           <p:cNvSpPr txBox="1"/>
           <p:nvPr/>
         </p:nvSpPr>
@@ -4191,7 +4492,7 @@
       </p:sp>
       <p:sp>
         <p:nvSpPr>
-          <p:cNvPr id="12" name="card-222"/>
+          <p:cNvPr id="12" name="card-221"/>
           <p:cNvSpPr/>
           <p:nvPr/>
         </p:nvSpPr>
@@ -4225,7 +4526,7 @@
       </p:sp>
       <p:sp>
         <p:nvSpPr>
-          <p:cNvPr id="13" name="text-223"/>
+          <p:cNvPr id="13" name="text-222"/>
           <p:cNvSpPr txBox="1"/>
           <p:nvPr/>
         </p:nvSpPr>
@@ -4261,7 +4562,7 @@
       </p:sp>
       <p:sp>
         <p:nvSpPr>
-          <p:cNvPr id="14" name="text-224"/>
+          <p:cNvPr id="14" name="text-223"/>
           <p:cNvSpPr txBox="1"/>
           <p:nvPr/>
         </p:nvSpPr>
@@ -4297,7 +4598,7 @@
       </p:sp>
       <p:sp>
         <p:nvSpPr>
-          <p:cNvPr id="15" name="card-225"/>
+          <p:cNvPr id="15" name="card-224"/>
           <p:cNvSpPr/>
           <p:nvPr/>
         </p:nvSpPr>
@@ -4331,7 +4632,7 @@
       </p:sp>
       <p:sp>
         <p:nvSpPr>
-          <p:cNvPr id="16" name="text-226"/>
+          <p:cNvPr id="16" name="text-225"/>
           <p:cNvSpPr txBox="1"/>
           <p:nvPr/>
         </p:nvSpPr>
@@ -4367,7 +4668,7 @@
       </p:sp>
       <p:sp>
         <p:nvSpPr>
-          <p:cNvPr id="17" name="list-227"/>
+          <p:cNvPr id="17" name="list-226"/>
           <p:cNvSpPr txBox="1"/>
           <p:nvPr/>
         </p:nvSpPr>
@@ -11316,16 +11617,32 @@
           </a:p>
         </p:txBody>
       </p:sp>
-      <p:sp>
-        <p:nvSpPr>
-          <p:cNvPr id="3" name="card-169"/>
+      <p:graphicFrame>
+        <p:nvGraphicFramePr>
+          <p:cNvPr id="3" name="Chart 0" descr=""/>
+          <p:cNvGraphicFramePr/>
+          <p:nvPr/>
+        </p:nvGraphicFramePr>
+        <p:xfrm>
+          <a:off x="365760" y="1051560"/>
+          <a:ext cx="5120640" cy="3566160"/>
+        </p:xfrm>
+        <a:graphic xmlns:a="http://schemas.openxmlformats.org/drawingml/2006/main">
+          <a:graphicData uri="http://schemas.openxmlformats.org/drawingml/2006/chart">
+            <c:chart xmlns:c="http://schemas.openxmlformats.org/drawingml/2006/chart" r:id="rId1"/>
+          </a:graphicData>
+        </a:graphic>
+      </p:graphicFrame>
+      <p:sp>
+        <p:nvSpPr>
+          <p:cNvPr id="4" name="card-169"/>
           <p:cNvSpPr/>
           <p:nvPr/>
         </p:nvSpPr>
         <p:spPr>
           <a:xfrm>
-            <a:off x="365760" y="1051560"/>
-            <a:ext cx="5120640" cy="1051560"/>
+            <a:off x="5760720" y="1051560"/>
+            <a:ext cx="3017520" cy="1051560"/>
           </a:xfrm>
           <a:prstGeom prst="roundRect">
             <a:avLst>
@@ -11352,14 +11669,14 @@
       </p:sp>
       <p:sp>
         <p:nvSpPr>
-          <p:cNvPr id="4" name="text-170"/>
-          <p:cNvSpPr txBox="1"/>
-          <p:nvPr/>
-        </p:nvSpPr>
-        <p:spPr>
-          <a:xfrm>
-            <a:off x="548640" y="1097280"/>
-            <a:ext cx="1737360" cy="960120"/>
+          <p:cNvPr id="5" name="text-170"/>
+          <p:cNvSpPr txBox="1"/>
+          <p:nvPr/>
+        </p:nvSpPr>
+        <p:spPr>
+          <a:xfrm>
+            <a:off x="5897880" y="1097280"/>
+            <a:ext cx="2743200" cy="502920"/>
           </a:xfrm>
           <a:prstGeom prst="rect">
             <a:avLst/>
@@ -11375,7 +11692,7 @@
               <a:buNone/>
             </a:pPr>
             <a:r>
-              <a:rPr lang="en-US" sz="2800" b="1" dirty="0">
+              <a:rPr lang="en-US" sz="2600" b="1" dirty="0">
                 <a:solidFill>
                   <a:schemeClr val="tx2"/>
                 </a:solidFill>
@@ -11383,22 +11700,22 @@
                 <a:ea typeface="Cambria" pitchFamily="34" charset="-122"/>
                 <a:cs typeface="Cambria" pitchFamily="34" charset="-120"/>
               </a:rPr>
-              <a:t>7</a:t>
-            </a:r>
-            <a:endParaRPr lang="en-US" sz="2800" dirty="0"/>
-          </a:p>
-        </p:txBody>
-      </p:sp>
-      <p:sp>
-        <p:nvSpPr>
-          <p:cNvPr id="5" name="text-171"/>
-          <p:cNvSpPr txBox="1"/>
-          <p:nvPr/>
-        </p:nvSpPr>
-        <p:spPr>
-          <a:xfrm>
-            <a:off x="2286000" y="1097280"/>
-            <a:ext cx="3108960" cy="960120"/>
+              <a:t>100%</a:t>
+            </a:r>
+            <a:endParaRPr lang="en-US" sz="2600" dirty="0"/>
+          </a:p>
+        </p:txBody>
+      </p:sp>
+      <p:sp>
+        <p:nvSpPr>
+          <p:cNvPr id="6" name="text-171"/>
+          <p:cNvSpPr txBox="1"/>
+          <p:nvPr/>
+        </p:nvSpPr>
+        <p:spPr>
+          <a:xfrm>
+            <a:off x="5897880" y="1572768"/>
+            <a:ext cx="2743200" cy="457200"/>
           </a:xfrm>
           <a:prstGeom prst="rect">
             <a:avLst/>
@@ -11414,27 +11731,27 @@
               <a:buNone/>
             </a:pPr>
             <a:r>
-              <a:rPr lang="en-US" sz="1300" dirty="0">
+              <a:rPr lang="en-US" sz="1100" dirty="0">
                 <a:solidFill>
                   <a:schemeClr val="tx1"/>
                 </a:solidFill>
               </a:rPr>
-              <a:t>detectors with zero false alarms on 7,003 clean invoices</a:t>
-            </a:r>
-            <a:endParaRPr lang="en-US" sz="1300" dirty="0"/>
-          </a:p>
-        </p:txBody>
-      </p:sp>
-      <p:sp>
-        <p:nvSpPr>
-          <p:cNvPr id="6" name="card-172"/>
+              <a:t>of planted irregularities caught</a:t>
+            </a:r>
+            <a:endParaRPr lang="en-US" sz="1100" dirty="0"/>
+          </a:p>
+        </p:txBody>
+      </p:sp>
+      <p:sp>
+        <p:nvSpPr>
+          <p:cNvPr id="7" name="card-172"/>
           <p:cNvSpPr/>
           <p:nvPr/>
         </p:nvSpPr>
         <p:spPr>
           <a:xfrm>
-            <a:off x="365760" y="2240280"/>
-            <a:ext cx="5120640" cy="1051560"/>
+            <a:off x="5760720" y="2240280"/>
+            <a:ext cx="3017520" cy="1051560"/>
           </a:xfrm>
           <a:prstGeom prst="roundRect">
             <a:avLst>
@@ -11461,14 +11778,14 @@
       </p:sp>
       <p:sp>
         <p:nvSpPr>
-          <p:cNvPr id="7" name="text-173"/>
-          <p:cNvSpPr txBox="1"/>
-          <p:nvPr/>
-        </p:nvSpPr>
-        <p:spPr>
-          <a:xfrm>
-            <a:off x="548640" y="2286000"/>
-            <a:ext cx="1737360" cy="960120"/>
+          <p:cNvPr id="8" name="text-173"/>
+          <p:cNvSpPr txBox="1"/>
+          <p:nvPr/>
+        </p:nvSpPr>
+        <p:spPr>
+          <a:xfrm>
+            <a:off x="5897880" y="2286000"/>
+            <a:ext cx="2743200" cy="502920"/>
           </a:xfrm>
           <a:prstGeom prst="rect">
             <a:avLst/>
@@ -11484,7 +11801,7 @@
               <a:buNone/>
             </a:pPr>
             <a:r>
-              <a:rPr lang="en-US" sz="2800" b="1" dirty="0">
+              <a:rPr lang="en-US" sz="2600" b="1" dirty="0">
                 <a:solidFill>
                   <a:schemeClr val="tx2"/>
                 </a:solidFill>
@@ -11492,22 +11809,22 @@
                 <a:ea typeface="Cambria" pitchFamily="34" charset="-122"/>
                 <a:cs typeface="Cambria" pitchFamily="34" charset="-120"/>
               </a:rPr>
-              <a:t>4 cycles</a:t>
-            </a:r>
-            <a:endParaRPr lang="en-US" sz="2800" dirty="0"/>
-          </a:p>
-        </p:txBody>
-      </p:sp>
-      <p:sp>
-        <p:nvSpPr>
-          <p:cNvPr id="8" name="text-174"/>
-          <p:cNvSpPr txBox="1"/>
-          <p:nvPr/>
-        </p:nvSpPr>
-        <p:spPr>
-          <a:xfrm>
-            <a:off x="2286000" y="2286000"/>
-            <a:ext cx="3108960" cy="960120"/>
+              <a:t>100%</a:t>
+            </a:r>
+            <a:endParaRPr lang="en-US" sz="2600" dirty="0"/>
+          </a:p>
+        </p:txBody>
+      </p:sp>
+      <p:sp>
+        <p:nvSpPr>
+          <p:cNvPr id="9" name="text-174"/>
+          <p:cNvSpPr txBox="1"/>
+          <p:nvPr/>
+        </p:nvSpPr>
+        <p:spPr>
+          <a:xfrm>
+            <a:off x="5897880" y="2761488"/>
+            <a:ext cx="2743200" cy="457200"/>
           </a:xfrm>
           <a:prstGeom prst="rect">
             <a:avLst/>
@@ -11523,27 +11840,27 @@
               <a:buNone/>
             </a:pPr>
             <a:r>
-              <a:rPr lang="en-US" sz="1300" dirty="0">
+              <a:rPr lang="en-US" sz="1100" dirty="0">
                 <a:solidFill>
                   <a:schemeClr val="tx1"/>
                 </a:solidFill>
               </a:rPr>
-              <a:t>found in the planted trading network: ₹5.64 Cr circular value</a:t>
-            </a:r>
-            <a:endParaRPr lang="en-US" sz="1300" dirty="0"/>
-          </a:p>
-        </p:txBody>
-      </p:sp>
-      <p:sp>
-        <p:nvSpPr>
-          <p:cNvPr id="9" name="card-175"/>
+              <a:t>precision of severity-4+ hits</a:t>
+            </a:r>
+            <a:endParaRPr lang="en-US" sz="1100" dirty="0"/>
+          </a:p>
+        </p:txBody>
+      </p:sp>
+      <p:sp>
+        <p:nvSpPr>
+          <p:cNvPr id="10" name="card-175"/>
           <p:cNvSpPr/>
           <p:nvPr/>
         </p:nvSpPr>
         <p:spPr>
           <a:xfrm>
-            <a:off x="365760" y="3429000"/>
-            <a:ext cx="5120640" cy="1051560"/>
+            <a:off x="5760720" y="3429000"/>
+            <a:ext cx="3017520" cy="1051560"/>
           </a:xfrm>
           <a:prstGeom prst="roundRect">
             <a:avLst>
@@ -11570,14 +11887,14 @@
       </p:sp>
       <p:sp>
         <p:nvSpPr>
-          <p:cNvPr id="10" name="text-176"/>
-          <p:cNvSpPr txBox="1"/>
-          <p:nvPr/>
-        </p:nvSpPr>
-        <p:spPr>
-          <a:xfrm>
-            <a:off x="548640" y="3474720"/>
-            <a:ext cx="1737360" cy="960120"/>
+          <p:cNvPr id="11" name="text-176"/>
+          <p:cNvSpPr txBox="1"/>
+          <p:nvPr/>
+        </p:nvSpPr>
+        <p:spPr>
+          <a:xfrm>
+            <a:off x="5897880" y="3474720"/>
+            <a:ext cx="2743200" cy="502920"/>
           </a:xfrm>
           <a:prstGeom prst="rect">
             <a:avLst/>
@@ -11593,7 +11910,7 @@
               <a:buNone/>
             </a:pPr>
             <a:r>
-              <a:rPr lang="en-US" sz="2800" b="1" dirty="0">
+              <a:rPr lang="en-US" sz="2600" b="1" dirty="0">
                 <a:solidFill>
                   <a:schemeClr val="tx2"/>
                 </a:solidFill>
@@ -11601,22 +11918,22 @@
                 <a:ea typeface="Cambria" pitchFamily="34" charset="-122"/>
                 <a:cs typeface="Cambria" pitchFamily="34" charset="-120"/>
               </a:rPr>
-              <a:t>~7 s</a:t>
-            </a:r>
-            <a:endParaRPr lang="en-US" sz="2800" dirty="0"/>
-          </a:p>
-        </p:txBody>
-      </p:sp>
-      <p:sp>
-        <p:nvSpPr>
-          <p:cNvPr id="11" name="text-177"/>
-          <p:cNvSpPr txBox="1"/>
-          <p:nvPr/>
-        </p:nvSpPr>
-        <p:spPr>
-          <a:xfrm>
-            <a:off x="2286000" y="3474720"/>
-            <a:ext cx="3108960" cy="960120"/>
+              <a:t>~2 s</a:t>
+            </a:r>
+            <a:endParaRPr lang="en-US" sz="2600" dirty="0"/>
+          </a:p>
+        </p:txBody>
+      </p:sp>
+      <p:sp>
+        <p:nvSpPr>
+          <p:cNvPr id="12" name="text-177"/>
+          <p:cNvSpPr txBox="1"/>
+          <p:nvPr/>
+        </p:nvSpPr>
+        <p:spPr>
+          <a:xfrm>
+            <a:off x="5897880" y="3950208"/>
+            <a:ext cx="2743200" cy="457200"/>
           </a:xfrm>
           <a:prstGeom prst="rect">
             <a:avLst/>
@@ -11632,56 +11949,20 @@
               <a:buNone/>
             </a:pPr>
             <a:r>
-              <a:rPr lang="en-US" sz="1300" dirty="0">
+              <a:rPr lang="en-US" sz="1100" dirty="0">
                 <a:solidFill>
                   <a:schemeClr val="tx1"/>
                 </a:solidFill>
               </a:rPr>
-              <a:t>to run all detectors over 100% of the year on a laptop CPU</a:t>
-            </a:r>
-            <a:endParaRPr lang="en-US" sz="1300" dirty="0"/>
-          </a:p>
-        </p:txBody>
-      </p:sp>
-      <p:sp>
-        <p:nvSpPr>
-          <p:cNvPr id="12" name="text-178"/>
-          <p:cNvSpPr txBox="1"/>
-          <p:nvPr/>
-        </p:nvSpPr>
-        <p:spPr>
-          <a:xfrm>
-            <a:off x="5760720" y="1051560"/>
-            <a:ext cx="3017520" cy="3291840"/>
-          </a:xfrm>
-          <a:prstGeom prst="rect">
-            <a:avLst/>
-          </a:prstGeom>
-          <a:noFill/>
-          <a:ln/>
-        </p:spPr>
-        <p:txBody>
-          <a:bodyPr wrap="square" rtlCol="0" anchor="ctr"/>
-          <a:lstStyle/>
-          <a:p>
-            <a:pPr indent="0" marL="0">
-              <a:buNone/>
-            </a:pPr>
-            <a:r>
-              <a:rPr lang="en-US" sz="1300" i="1" dirty="0">
-                <a:solidFill>
-                  <a:schemeClr val="accent4"/>
-                </a:solidFill>
-              </a:rPr>
-              <a:t>Recall per irregularity family and the AuditGraph ablation appear here once the planted set and answer key are complete (python -m app.evaluate).</a:t>
-            </a:r>
-            <a:endParaRPr lang="en-US" sz="1300" dirty="0"/>
-          </a:p>
-        </p:txBody>
-      </p:sp>
-      <p:sp>
-        <p:nvSpPr>
-          <p:cNvPr id="13" name="text-179"/>
+              <a:t>from a client's live edit to the updated risk score (whole audit &lt; 1 min)</a:t>
+            </a:r>
+            <a:endParaRPr lang="en-US" sz="1100" dirty="0"/>
+          </a:p>
+        </p:txBody>
+      </p:sp>
+      <p:sp>
+        <p:nvSpPr>
+          <p:cNvPr id="13" name="text-178"/>
           <p:cNvSpPr txBox="1"/>
           <p:nvPr/>
         </p:nvSpPr>

</xml_diff>